<commit_message>
updated and consolidated different card fields + added hints to phenomena cards
</commit_message>
<xml_diff>
--- a/bhns_card_images/phenomena/BH_NS_phenomena.pptx
+++ b/bhns_card_images/phenomena/BH_NS_phenomena.pptx
@@ -16882,7 +16882,7 @@
         </p:nvGrpSpPr>
         <p:grpSpPr>
           <a:xfrm>
-            <a:off x="6711696" y="4210282"/>
+            <a:off x="5068033" y="3117236"/>
             <a:ext cx="2114122" cy="2389149"/>
             <a:chOff x="6711696" y="4210282"/>
             <a:chExt cx="2114122" cy="2389149"/>
@@ -18384,10 +18384,10 @@
       </p:grpSp>
       <p:grpSp>
         <p:nvGrpSpPr>
-          <p:cNvPr id="139" name="Group 138">
+          <p:cNvPr id="160" name="Group 159">
             <a:extLst>
               <a:ext uri="{FF2B5EF4-FFF2-40B4-BE49-F238E27FC236}">
-                <a16:creationId xmlns:a16="http://schemas.microsoft.com/office/drawing/2014/main" id="{C51A6848-432B-7290-11D6-849BE19A4428}"/>
+                <a16:creationId xmlns:a16="http://schemas.microsoft.com/office/drawing/2014/main" id="{F00758A1-D20D-F98F-1320-8BE9E6E7C1B7}"/>
               </a:ext>
             </a:extLst>
           </p:cNvPr>
@@ -18398,101 +18398,16 @@
           <a:xfrm>
             <a:off x="9050216" y="4729404"/>
             <a:ext cx="2114122" cy="2389149"/>
-            <a:chOff x="6711696" y="4210282"/>
+            <a:chOff x="9050216" y="4729404"/>
             <a:chExt cx="2114122" cy="2389149"/>
           </a:xfrm>
         </p:grpSpPr>
-        <p:sp>
-          <p:nvSpPr>
-            <p:cNvPr id="140" name="Doughnut 96">
+        <p:grpSp>
+          <p:nvGrpSpPr>
+            <p:cNvPr id="139" name="Group 138">
               <a:extLst>
                 <a:ext uri="{FF2B5EF4-FFF2-40B4-BE49-F238E27FC236}">
-                  <a16:creationId xmlns:a16="http://schemas.microsoft.com/office/drawing/2014/main" id="{9AAB3CF9-D99D-3435-8825-1D327E279463}"/>
-                </a:ext>
-              </a:extLst>
-            </p:cNvPr>
-            <p:cNvSpPr/>
-            <p:nvPr/>
-          </p:nvSpPr>
-          <p:spPr>
-            <a:xfrm rot="21266905">
-              <a:off x="6711696" y="4210282"/>
-              <a:ext cx="2114122" cy="2389149"/>
-            </a:xfrm>
-            <a:prstGeom prst="donut">
-              <a:avLst>
-                <a:gd name="adj" fmla="val 30689"/>
-              </a:avLst>
-            </a:prstGeom>
-            <a:gradFill>
-              <a:gsLst>
-                <a:gs pos="75000">
-                  <a:srgbClr val="82ADE4">
-                    <a:lumMod val="69000"/>
-                  </a:srgbClr>
-                </a:gs>
-                <a:gs pos="53000">
-                  <a:srgbClr val="A2D1EC"/>
-                </a:gs>
-                <a:gs pos="42000">
-                  <a:srgbClr val="699ECF"/>
-                </a:gs>
-                <a:gs pos="12000">
-                  <a:srgbClr val="E6F5FB"/>
-                </a:gs>
-              </a:gsLst>
-              <a:path path="circle">
-                <a:fillToRect l="50000" t="50000" r="50000" b="50000"/>
-              </a:path>
-            </a:gradFill>
-            <a:ln>
-              <a:noFill/>
-            </a:ln>
-            <a:scene3d>
-              <a:camera prst="orthographicFront">
-                <a:rot lat="16799982" lon="0" rev="0"/>
-              </a:camera>
-              <a:lightRig rig="threePt" dir="t"/>
-            </a:scene3d>
-          </p:spPr>
-          <p:style>
-            <a:lnRef idx="2">
-              <a:schemeClr val="accent1">
-                <a:shade val="50000"/>
-              </a:schemeClr>
-            </a:lnRef>
-            <a:fillRef idx="1">
-              <a:schemeClr val="accent1"/>
-            </a:fillRef>
-            <a:effectRef idx="0">
-              <a:schemeClr val="accent1"/>
-            </a:effectRef>
-            <a:fontRef idx="minor">
-              <a:schemeClr val="lt1"/>
-            </a:fontRef>
-          </p:style>
-          <p:txBody>
-            <a:bodyPr rtlCol="0" anchor="ctr"/>
-            <a:lstStyle/>
-            <a:p>
-              <a:pPr algn="ctr">
-                <a:defRPr/>
-              </a:pPr>
-              <a:endParaRPr lang="en-GB" sz="1524" dirty="0">
-                <a:solidFill>
-                  <a:srgbClr val="000000"/>
-                </a:solidFill>
-                <a:latin typeface="Calibri" panose="020F0502020204030204"/>
-              </a:endParaRPr>
-            </a:p>
-          </p:txBody>
-        </p:sp>
-        <p:grpSp>
-          <p:nvGrpSpPr>
-            <p:cNvPr id="141" name="Group 140">
-              <a:extLst>
-                <a:ext uri="{FF2B5EF4-FFF2-40B4-BE49-F238E27FC236}">
-                  <a16:creationId xmlns:a16="http://schemas.microsoft.com/office/drawing/2014/main" id="{ED3D245E-AE04-D983-A897-6FCE99149146}"/>
+                  <a16:creationId xmlns:a16="http://schemas.microsoft.com/office/drawing/2014/main" id="{C51A6848-432B-7290-11D6-849BE19A4428}"/>
                 </a:ext>
               </a:extLst>
             </p:cNvPr>
@@ -18501,18 +18416,18 @@
           </p:nvGrpSpPr>
           <p:grpSpPr>
             <a:xfrm>
-              <a:off x="6928453" y="4447519"/>
-              <a:ext cx="1689004" cy="1908728"/>
-              <a:chOff x="6928453" y="4447519"/>
-              <a:chExt cx="1689004" cy="1908728"/>
+              <a:off x="9050216" y="4729404"/>
+              <a:ext cx="2114122" cy="2389149"/>
+              <a:chOff x="6711696" y="4210282"/>
+              <a:chExt cx="2114122" cy="2389149"/>
             </a:xfrm>
           </p:grpSpPr>
           <p:sp>
             <p:nvSpPr>
-              <p:cNvPr id="143" name="Oval 142">
+              <p:cNvPr id="140" name="Doughnut 96">
                 <a:extLst>
                   <a:ext uri="{FF2B5EF4-FFF2-40B4-BE49-F238E27FC236}">
-                    <a16:creationId xmlns:a16="http://schemas.microsoft.com/office/drawing/2014/main" id="{895FC2C3-6DC5-07D2-80FB-949988950173}"/>
+                    <a16:creationId xmlns:a16="http://schemas.microsoft.com/office/drawing/2014/main" id="{9AAB3CF9-D99D-3435-8825-1D327E279463}"/>
                   </a:ext>
                 </a:extLst>
               </p:cNvPr>
@@ -18520,77 +18435,36 @@
               <p:nvPr/>
             </p:nvSpPr>
             <p:spPr>
-              <a:xfrm>
-                <a:off x="7387569" y="5590791"/>
-                <a:ext cx="54704" cy="56801"/>
-              </a:xfrm>
-              <a:prstGeom prst="ellipse">
-                <a:avLst/>
-              </a:prstGeom>
-              <a:solidFill>
-                <a:schemeClr val="tx1"/>
-              </a:solidFill>
-              <a:ln>
-                <a:noFill/>
-              </a:ln>
-            </p:spPr>
-            <p:style>
-              <a:lnRef idx="2">
-                <a:schemeClr val="accent1">
-                  <a:shade val="50000"/>
-                </a:schemeClr>
-              </a:lnRef>
-              <a:fillRef idx="1">
-                <a:schemeClr val="accent1"/>
-              </a:fillRef>
-              <a:effectRef idx="0">
-                <a:schemeClr val="accent1"/>
-              </a:effectRef>
-              <a:fontRef idx="minor">
-                <a:schemeClr val="lt1"/>
-              </a:fontRef>
-            </p:style>
-            <p:txBody>
-              <a:bodyPr rtlCol="0" anchor="ctr"/>
-              <a:lstStyle/>
-              <a:p>
-                <a:pPr algn="ctr">
-                  <a:defRPr/>
-                </a:pPr>
-                <a:endParaRPr lang="en-GB" sz="1524" dirty="0">
-                  <a:solidFill>
-                    <a:srgbClr val="000000"/>
-                  </a:solidFill>
-                  <a:latin typeface="Calibri" panose="020F0502020204030204"/>
-                </a:endParaRPr>
-              </a:p>
-            </p:txBody>
-          </p:sp>
-          <p:sp>
-            <p:nvSpPr>
-              <p:cNvPr id="144" name="Doughnut 97">
-                <a:extLst>
-                  <a:ext uri="{FF2B5EF4-FFF2-40B4-BE49-F238E27FC236}">
-                    <a16:creationId xmlns:a16="http://schemas.microsoft.com/office/drawing/2014/main" id="{E1DEC2D9-863A-D658-C5F8-E5D230E7D833}"/>
-                  </a:ext>
-                </a:extLst>
-              </p:cNvPr>
-              <p:cNvSpPr/>
-              <p:nvPr/>
-            </p:nvSpPr>
-            <p:spPr>
-              <a:xfrm rot="21249571">
-                <a:off x="6928453" y="4447519"/>
-                <a:ext cx="1689004" cy="1908728"/>
+              <a:xfrm rot="21266905">
+                <a:off x="6711696" y="4210282"/>
+                <a:ext cx="2114122" cy="2389149"/>
               </a:xfrm>
               <a:prstGeom prst="donut">
                 <a:avLst>
-                  <a:gd name="adj" fmla="val 6235"/>
+                  <a:gd name="adj" fmla="val 30689"/>
                 </a:avLst>
               </a:prstGeom>
-              <a:solidFill>
-                <a:srgbClr val="68A0D2"/>
-              </a:solidFill>
+              <a:gradFill>
+                <a:gsLst>
+                  <a:gs pos="75000">
+                    <a:srgbClr val="82ADE4">
+                      <a:lumMod val="69000"/>
+                    </a:srgbClr>
+                  </a:gs>
+                  <a:gs pos="53000">
+                    <a:srgbClr val="A2D1EC"/>
+                  </a:gs>
+                  <a:gs pos="42000">
+                    <a:srgbClr val="699ECF"/>
+                  </a:gs>
+                  <a:gs pos="12000">
+                    <a:srgbClr val="E6F5FB"/>
+                  </a:gs>
+                </a:gsLst>
+                <a:path path="circle">
+                  <a:fillToRect l="50000" t="50000" r="50000" b="50000"/>
+                </a:path>
+              </a:gradFill>
               <a:ln>
                 <a:noFill/>
               </a:ln>
@@ -18633,166 +18507,313 @@
               </a:p>
             </p:txBody>
           </p:sp>
-          <p:sp>
-            <p:nvSpPr>
-              <p:cNvPr id="145" name="Oval 144">
+          <p:grpSp>
+            <p:nvGrpSpPr>
+              <p:cNvPr id="141" name="Group 140">
                 <a:extLst>
                   <a:ext uri="{FF2B5EF4-FFF2-40B4-BE49-F238E27FC236}">
-                    <a16:creationId xmlns:a16="http://schemas.microsoft.com/office/drawing/2014/main" id="{537116E6-1AA6-6AA7-8F2A-D40FBBC78A18}"/>
+                    <a16:creationId xmlns:a16="http://schemas.microsoft.com/office/drawing/2014/main" id="{ED3D245E-AE04-D983-A897-6FCE99149146}"/>
                   </a:ext>
                 </a:extLst>
               </p:cNvPr>
-              <p:cNvSpPr/>
+              <p:cNvGrpSpPr/>
               <p:nvPr/>
-            </p:nvSpPr>
-            <p:spPr>
+            </p:nvGrpSpPr>
+            <p:grpSpPr>
               <a:xfrm>
-                <a:off x="7706317" y="5296651"/>
-                <a:ext cx="171338" cy="177906"/>
+                <a:off x="6928453" y="4447519"/>
+                <a:ext cx="1689004" cy="1908728"/>
+                <a:chOff x="6928453" y="4447519"/>
+                <a:chExt cx="1689004" cy="1908728"/>
               </a:xfrm>
-              <a:prstGeom prst="ellipse">
-                <a:avLst/>
-              </a:prstGeom>
-              <a:solidFill>
-                <a:schemeClr val="tx1"/>
-              </a:solidFill>
-              <a:ln>
-                <a:noFill/>
-              </a:ln>
-            </p:spPr>
-            <p:style>
-              <a:lnRef idx="2">
-                <a:schemeClr val="accent1">
-                  <a:shade val="50000"/>
-                </a:schemeClr>
-              </a:lnRef>
-              <a:fillRef idx="1">
-                <a:schemeClr val="accent1"/>
-              </a:fillRef>
-              <a:effectRef idx="0">
-                <a:schemeClr val="accent1"/>
-              </a:effectRef>
-              <a:fontRef idx="minor">
-                <a:schemeClr val="lt1"/>
-              </a:fontRef>
-            </p:style>
-            <p:txBody>
-              <a:bodyPr rtlCol="0" anchor="ctr"/>
-              <a:lstStyle/>
-              <a:p>
-                <a:pPr algn="ctr">
-                  <a:defRPr/>
-                </a:pPr>
-                <a:endParaRPr lang="en-GB" sz="1524" dirty="0">
-                  <a:solidFill>
-                    <a:srgbClr val="000000"/>
-                  </a:solidFill>
-                  <a:latin typeface="Calibri" panose="020F0502020204030204"/>
-                </a:endParaRPr>
-              </a:p>
-            </p:txBody>
-          </p:sp>
+            </p:grpSpPr>
+            <p:sp>
+              <p:nvSpPr>
+                <p:cNvPr id="143" name="Oval 142">
+                  <a:extLst>
+                    <a:ext uri="{FF2B5EF4-FFF2-40B4-BE49-F238E27FC236}">
+                      <a16:creationId xmlns:a16="http://schemas.microsoft.com/office/drawing/2014/main" id="{895FC2C3-6DC5-07D2-80FB-949988950173}"/>
+                    </a:ext>
+                  </a:extLst>
+                </p:cNvPr>
+                <p:cNvSpPr/>
+                <p:nvPr/>
+              </p:nvSpPr>
+              <p:spPr>
+                <a:xfrm>
+                  <a:off x="7387569" y="5590791"/>
+                  <a:ext cx="54704" cy="56801"/>
+                </a:xfrm>
+                <a:prstGeom prst="ellipse">
+                  <a:avLst/>
+                </a:prstGeom>
+                <a:solidFill>
+                  <a:schemeClr val="tx1"/>
+                </a:solidFill>
+                <a:ln>
+                  <a:noFill/>
+                </a:ln>
+              </p:spPr>
+              <p:style>
+                <a:lnRef idx="2">
+                  <a:schemeClr val="accent1">
+                    <a:shade val="50000"/>
+                  </a:schemeClr>
+                </a:lnRef>
+                <a:fillRef idx="1">
+                  <a:schemeClr val="accent1"/>
+                </a:fillRef>
+                <a:effectRef idx="0">
+                  <a:schemeClr val="accent1"/>
+                </a:effectRef>
+                <a:fontRef idx="minor">
+                  <a:schemeClr val="lt1"/>
+                </a:fontRef>
+              </p:style>
+              <p:txBody>
+                <a:bodyPr rtlCol="0" anchor="ctr"/>
+                <a:lstStyle/>
+                <a:p>
+                  <a:pPr algn="ctr">
+                    <a:defRPr/>
+                  </a:pPr>
+                  <a:endParaRPr lang="en-GB" sz="1524" dirty="0">
+                    <a:solidFill>
+                      <a:srgbClr val="000000"/>
+                    </a:solidFill>
+                    <a:latin typeface="Calibri" panose="020F0502020204030204"/>
+                  </a:endParaRPr>
+                </a:p>
+              </p:txBody>
+            </p:sp>
+            <p:sp>
+              <p:nvSpPr>
+                <p:cNvPr id="144" name="Doughnut 97">
+                  <a:extLst>
+                    <a:ext uri="{FF2B5EF4-FFF2-40B4-BE49-F238E27FC236}">
+                      <a16:creationId xmlns:a16="http://schemas.microsoft.com/office/drawing/2014/main" id="{E1DEC2D9-863A-D658-C5F8-E5D230E7D833}"/>
+                    </a:ext>
+                  </a:extLst>
+                </p:cNvPr>
+                <p:cNvSpPr/>
+                <p:nvPr/>
+              </p:nvSpPr>
+              <p:spPr>
+                <a:xfrm rot="21249571">
+                  <a:off x="6928453" y="4447519"/>
+                  <a:ext cx="1689004" cy="1908728"/>
+                </a:xfrm>
+                <a:prstGeom prst="donut">
+                  <a:avLst>
+                    <a:gd name="adj" fmla="val 6235"/>
+                  </a:avLst>
+                </a:prstGeom>
+                <a:solidFill>
+                  <a:srgbClr val="68A0D2"/>
+                </a:solidFill>
+                <a:ln>
+                  <a:noFill/>
+                </a:ln>
+                <a:scene3d>
+                  <a:camera prst="orthographicFront">
+                    <a:rot lat="16799982" lon="0" rev="0"/>
+                  </a:camera>
+                  <a:lightRig rig="threePt" dir="t"/>
+                </a:scene3d>
+              </p:spPr>
+              <p:style>
+                <a:lnRef idx="2">
+                  <a:schemeClr val="accent1">
+                    <a:shade val="50000"/>
+                  </a:schemeClr>
+                </a:lnRef>
+                <a:fillRef idx="1">
+                  <a:schemeClr val="accent1"/>
+                </a:fillRef>
+                <a:effectRef idx="0">
+                  <a:schemeClr val="accent1"/>
+                </a:effectRef>
+                <a:fontRef idx="minor">
+                  <a:schemeClr val="lt1"/>
+                </a:fontRef>
+              </p:style>
+              <p:txBody>
+                <a:bodyPr rtlCol="0" anchor="ctr"/>
+                <a:lstStyle/>
+                <a:p>
+                  <a:pPr algn="ctr">
+                    <a:defRPr/>
+                  </a:pPr>
+                  <a:endParaRPr lang="en-GB" sz="1524" dirty="0">
+                    <a:solidFill>
+                      <a:srgbClr val="000000"/>
+                    </a:solidFill>
+                    <a:latin typeface="Calibri" panose="020F0502020204030204"/>
+                  </a:endParaRPr>
+                </a:p>
+              </p:txBody>
+            </p:sp>
+            <p:sp>
+              <p:nvSpPr>
+                <p:cNvPr id="145" name="Oval 144">
+                  <a:extLst>
+                    <a:ext uri="{FF2B5EF4-FFF2-40B4-BE49-F238E27FC236}">
+                      <a16:creationId xmlns:a16="http://schemas.microsoft.com/office/drawing/2014/main" id="{537116E6-1AA6-6AA7-8F2A-D40FBBC78A18}"/>
+                    </a:ext>
+                  </a:extLst>
+                </p:cNvPr>
+                <p:cNvSpPr/>
+                <p:nvPr/>
+              </p:nvSpPr>
+              <p:spPr>
+                <a:xfrm>
+                  <a:off x="7706317" y="5296651"/>
+                  <a:ext cx="171338" cy="177906"/>
+                </a:xfrm>
+                <a:prstGeom prst="ellipse">
+                  <a:avLst/>
+                </a:prstGeom>
+                <a:solidFill>
+                  <a:schemeClr val="tx1"/>
+                </a:solidFill>
+                <a:ln>
+                  <a:noFill/>
+                </a:ln>
+              </p:spPr>
+              <p:style>
+                <a:lnRef idx="2">
+                  <a:schemeClr val="accent1">
+                    <a:shade val="50000"/>
+                  </a:schemeClr>
+                </a:lnRef>
+                <a:fillRef idx="1">
+                  <a:schemeClr val="accent1"/>
+                </a:fillRef>
+                <a:effectRef idx="0">
+                  <a:schemeClr val="accent1"/>
+                </a:effectRef>
+                <a:fontRef idx="minor">
+                  <a:schemeClr val="lt1"/>
+                </a:fontRef>
+              </p:style>
+              <p:txBody>
+                <a:bodyPr rtlCol="0" anchor="ctr"/>
+                <a:lstStyle/>
+                <a:p>
+                  <a:pPr algn="ctr">
+                    <a:defRPr/>
+                  </a:pPr>
+                  <a:endParaRPr lang="en-GB" sz="1524" dirty="0">
+                    <a:solidFill>
+                      <a:srgbClr val="000000"/>
+                    </a:solidFill>
+                    <a:latin typeface="Calibri" panose="020F0502020204030204"/>
+                  </a:endParaRPr>
+                </a:p>
+              </p:txBody>
+            </p:sp>
+          </p:grpSp>
         </p:grpSp>
+        <p:sp>
+          <p:nvSpPr>
+            <p:cNvPr id="158" name="Freeform 157">
+              <a:extLst>
+                <a:ext uri="{FF2B5EF4-FFF2-40B4-BE49-F238E27FC236}">
+                  <a16:creationId xmlns:a16="http://schemas.microsoft.com/office/drawing/2014/main" id="{2B8DCF73-0D3B-4345-6C42-09C186A3C808}"/>
+                </a:ext>
+              </a:extLst>
+            </p:cNvPr>
+            <p:cNvSpPr/>
+            <p:nvPr/>
+          </p:nvSpPr>
+          <p:spPr>
+            <a:xfrm>
+              <a:off x="9846527" y="5859966"/>
+              <a:ext cx="513070" cy="262054"/>
+            </a:xfrm>
+            <a:custGeom>
+              <a:avLst/>
+              <a:gdLst>
+                <a:gd name="connsiteX0" fmla="*/ 0 w 513070"/>
+                <a:gd name="connsiteY0" fmla="*/ 262054 h 262054"/>
+                <a:gd name="connsiteX1" fmla="*/ 228600 w 513070"/>
+                <a:gd name="connsiteY1" fmla="*/ 211873 h 262054"/>
+                <a:gd name="connsiteX2" fmla="*/ 501805 w 513070"/>
+                <a:gd name="connsiteY2" fmla="*/ 72483 h 262054"/>
+                <a:gd name="connsiteX3" fmla="*/ 434897 w 513070"/>
+                <a:gd name="connsiteY3" fmla="*/ 0 h 262054"/>
+              </a:gdLst>
+              <a:ahLst/>
+              <a:cxnLst>
+                <a:cxn ang="0">
+                  <a:pos x="connsiteX0" y="connsiteY0"/>
+                </a:cxn>
+                <a:cxn ang="0">
+                  <a:pos x="connsiteX1" y="connsiteY1"/>
+                </a:cxn>
+                <a:cxn ang="0">
+                  <a:pos x="connsiteX2" y="connsiteY2"/>
+                </a:cxn>
+                <a:cxn ang="0">
+                  <a:pos x="connsiteX3" y="connsiteY3"/>
+                </a:cxn>
+              </a:cxnLst>
+              <a:rect l="l" t="t" r="r" b="b"/>
+              <a:pathLst>
+                <a:path w="513070" h="262054">
+                  <a:moveTo>
+                    <a:pt x="0" y="262054"/>
+                  </a:moveTo>
+                  <a:cubicBezTo>
+                    <a:pt x="72483" y="252761"/>
+                    <a:pt x="144966" y="243468"/>
+                    <a:pt x="228600" y="211873"/>
+                  </a:cubicBezTo>
+                  <a:cubicBezTo>
+                    <a:pt x="312234" y="180278"/>
+                    <a:pt x="467422" y="107795"/>
+                    <a:pt x="501805" y="72483"/>
+                  </a:cubicBezTo>
+                  <a:cubicBezTo>
+                    <a:pt x="536188" y="37171"/>
+                    <a:pt x="485542" y="18585"/>
+                    <a:pt x="434897" y="0"/>
+                  </a:cubicBezTo>
+                </a:path>
+              </a:pathLst>
+            </a:custGeom>
+            <a:noFill/>
+            <a:ln w="9525">
+              <a:prstDash val="dash"/>
+              <a:tailEnd type="triangle" w="sm" len="sm"/>
+            </a:ln>
+          </p:spPr>
+          <p:style>
+            <a:lnRef idx="2">
+              <a:schemeClr val="accent1">
+                <a:shade val="15000"/>
+              </a:schemeClr>
+            </a:lnRef>
+            <a:fillRef idx="1">
+              <a:schemeClr val="accent1"/>
+            </a:fillRef>
+            <a:effectRef idx="0">
+              <a:schemeClr val="accent1"/>
+            </a:effectRef>
+            <a:fontRef idx="minor">
+              <a:schemeClr val="lt1"/>
+            </a:fontRef>
+          </p:style>
+          <p:txBody>
+            <a:bodyPr rtlCol="0" anchor="ctr"/>
+            <a:lstStyle/>
+            <a:p>
+              <a:pPr algn="ctr"/>
+              <a:endParaRPr lang="en-NL"/>
+            </a:p>
+          </p:txBody>
+        </p:sp>
       </p:grpSp>
-      <p:sp>
-        <p:nvSpPr>
-          <p:cNvPr id="158" name="Freeform 157">
-            <a:extLst>
-              <a:ext uri="{FF2B5EF4-FFF2-40B4-BE49-F238E27FC236}">
-                <a16:creationId xmlns:a16="http://schemas.microsoft.com/office/drawing/2014/main" id="{2B8DCF73-0D3B-4345-6C42-09C186A3C808}"/>
-              </a:ext>
-            </a:extLst>
-          </p:cNvPr>
-          <p:cNvSpPr/>
-          <p:nvPr/>
-        </p:nvSpPr>
-        <p:spPr>
-          <a:xfrm>
-            <a:off x="9846527" y="5859966"/>
-            <a:ext cx="513070" cy="262054"/>
-          </a:xfrm>
-          <a:custGeom>
-            <a:avLst/>
-            <a:gdLst>
-              <a:gd name="connsiteX0" fmla="*/ 0 w 513070"/>
-              <a:gd name="connsiteY0" fmla="*/ 262054 h 262054"/>
-              <a:gd name="connsiteX1" fmla="*/ 228600 w 513070"/>
-              <a:gd name="connsiteY1" fmla="*/ 211873 h 262054"/>
-              <a:gd name="connsiteX2" fmla="*/ 501805 w 513070"/>
-              <a:gd name="connsiteY2" fmla="*/ 72483 h 262054"/>
-              <a:gd name="connsiteX3" fmla="*/ 434897 w 513070"/>
-              <a:gd name="connsiteY3" fmla="*/ 0 h 262054"/>
-            </a:gdLst>
-            <a:ahLst/>
-            <a:cxnLst>
-              <a:cxn ang="0">
-                <a:pos x="connsiteX0" y="connsiteY0"/>
-              </a:cxn>
-              <a:cxn ang="0">
-                <a:pos x="connsiteX1" y="connsiteY1"/>
-              </a:cxn>
-              <a:cxn ang="0">
-                <a:pos x="connsiteX2" y="connsiteY2"/>
-              </a:cxn>
-              <a:cxn ang="0">
-                <a:pos x="connsiteX3" y="connsiteY3"/>
-              </a:cxn>
-            </a:cxnLst>
-            <a:rect l="l" t="t" r="r" b="b"/>
-            <a:pathLst>
-              <a:path w="513070" h="262054">
-                <a:moveTo>
-                  <a:pt x="0" y="262054"/>
-                </a:moveTo>
-                <a:cubicBezTo>
-                  <a:pt x="72483" y="252761"/>
-                  <a:pt x="144966" y="243468"/>
-                  <a:pt x="228600" y="211873"/>
-                </a:cubicBezTo>
-                <a:cubicBezTo>
-                  <a:pt x="312234" y="180278"/>
-                  <a:pt x="467422" y="107795"/>
-                  <a:pt x="501805" y="72483"/>
-                </a:cubicBezTo>
-                <a:cubicBezTo>
-                  <a:pt x="536188" y="37171"/>
-                  <a:pt x="485542" y="18585"/>
-                  <a:pt x="434897" y="0"/>
-                </a:cubicBezTo>
-              </a:path>
-            </a:pathLst>
-          </a:custGeom>
-          <a:noFill/>
-          <a:ln w="9525">
-            <a:prstDash val="dash"/>
-            <a:tailEnd type="triangle" w="sm" len="sm"/>
-          </a:ln>
-        </p:spPr>
-        <p:style>
-          <a:lnRef idx="2">
-            <a:schemeClr val="accent1">
-              <a:shade val="15000"/>
-            </a:schemeClr>
-          </a:lnRef>
-          <a:fillRef idx="1">
-            <a:schemeClr val="accent1"/>
-          </a:fillRef>
-          <a:effectRef idx="0">
-            <a:schemeClr val="accent1"/>
-          </a:effectRef>
-          <a:fontRef idx="minor">
-            <a:schemeClr val="lt1"/>
-          </a:fontRef>
-        </p:style>
-        <p:txBody>
-          <a:bodyPr rtlCol="0" anchor="ctr"/>
-          <a:lstStyle/>
-          <a:p>
-            <a:pPr algn="ctr"/>
-            <a:endParaRPr lang="en-NL"/>
-          </a:p>
-        </p:txBody>
-      </p:sp>
     </p:spTree>
     <p:extLst>
       <p:ext uri="{BB962C8B-B14F-4D97-AF65-F5344CB8AC3E}">

</xml_diff>